<commit_message>
Fix changes on 2025-01-24
</commit_message>
<xml_diff>
--- a/Analytics/00-2 Исследование зависимостей/Presentation/00-2 Variables.pptx
+++ b/Analytics/00-2 Исследование зависимостей/Presentation/00-2 Variables.pptx
@@ -253,7 +253,7 @@
           <a:p>
             <a:fld id="{929D4DEE-AA18-4B6A-845C-60AFD9463AA2}" type="datetimeFigureOut">
               <a:rPr lang="ru-RU" smtClean="0"/>
-              <a:t>19.10.2024</a:t>
+              <a:t>22.01.2025</a:t>
             </a:fld>
             <a:endParaRPr lang="ru-RU"/>
           </a:p>
@@ -629,6 +629,133 @@
   <p:cSld>
     <p:spTree>
       <p:nvGrpSpPr>
+        <p:cNvPr id="1" name="Shape 476"/>
+        <p:cNvGrpSpPr/>
+        <p:nvPr/>
+      </p:nvGrpSpPr>
+      <p:grpSpPr>
+        <a:xfrm>
+          <a:off x="0" y="0"/>
+          <a:ext cx="0" cy="0"/>
+          <a:chOff x="0" y="0"/>
+          <a:chExt cx="0" cy="0"/>
+        </a:xfrm>
+      </p:grpSpPr>
+      <p:sp>
+        <p:nvSpPr>
+          <p:cNvPr id="477" name="Google Shape;477;p45:notes"/>
+          <p:cNvSpPr>
+            <a:spLocks noGrp="1" noRot="1" noChangeAspect="1"/>
+          </p:cNvSpPr>
+          <p:nvPr>
+            <p:ph type="sldImg" idx="2"/>
+          </p:nvPr>
+        </p:nvSpPr>
+        <p:spPr>
+          <a:xfrm>
+            <a:off x="381000" y="685800"/>
+            <a:ext cx="6096000" cy="3429000"/>
+          </a:xfrm>
+          <a:custGeom>
+            <a:avLst/>
+            <a:gdLst/>
+            <a:ahLst/>
+            <a:cxnLst/>
+            <a:rect l="l" t="t" r="r" b="b"/>
+            <a:pathLst>
+              <a:path w="120000" h="120000" extrusionOk="0">
+                <a:moveTo>
+                  <a:pt x="0" y="0"/>
+                </a:moveTo>
+                <a:lnTo>
+                  <a:pt x="120000" y="0"/>
+                </a:lnTo>
+                <a:lnTo>
+                  <a:pt x="120000" y="120000"/>
+                </a:lnTo>
+                <a:lnTo>
+                  <a:pt x="0" y="120000"/>
+                </a:lnTo>
+                <a:close/>
+              </a:path>
+            </a:pathLst>
+          </a:custGeom>
+          <a:noFill/>
+          <a:ln w="9525" cap="flat" cmpd="sng">
+            <a:solidFill>
+              <a:srgbClr val="000000"/>
+            </a:solidFill>
+            <a:prstDash val="solid"/>
+            <a:round/>
+            <a:headEnd type="none" w="sm" len="sm"/>
+            <a:tailEnd type="none" w="sm" len="sm"/>
+          </a:ln>
+        </p:spPr>
+      </p:sp>
+      <p:sp>
+        <p:nvSpPr>
+          <p:cNvPr id="478" name="Google Shape;478;p45:notes"/>
+          <p:cNvSpPr txBox="1">
+            <a:spLocks noGrp="1"/>
+          </p:cNvSpPr>
+          <p:nvPr>
+            <p:ph type="body" idx="1"/>
+          </p:nvPr>
+        </p:nvSpPr>
+        <p:spPr>
+          <a:xfrm>
+            <a:off x="685800" y="4343400"/>
+            <a:ext cx="5486400" cy="4114800"/>
+          </a:xfrm>
+          <a:prstGeom prst="rect">
+            <a:avLst/>
+          </a:prstGeom>
+          <a:noFill/>
+          <a:ln>
+            <a:noFill/>
+          </a:ln>
+        </p:spPr>
+        <p:txBody>
+          <a:bodyPr spcFirstLastPara="1" wrap="square" lIns="91425" tIns="91425" rIns="91425" bIns="91425" anchor="t" anchorCtr="0">
+            <a:noAutofit/>
+          </a:bodyPr>
+          <a:lstStyle/>
+          <a:p>
+            <a:pPr marL="0" lvl="0" indent="0" algn="l" rtl="0">
+              <a:lnSpc>
+                <a:spcPct val="100000"/>
+              </a:lnSpc>
+              <a:spcBef>
+                <a:spcPts val="0"/>
+              </a:spcBef>
+              <a:spcAft>
+                <a:spcPts val="0"/>
+              </a:spcAft>
+              <a:buSzPts val="1100"/>
+              <a:buNone/>
+            </a:pPr>
+            <a:endParaRPr/>
+          </a:p>
+        </p:txBody>
+      </p:sp>
+    </p:spTree>
+    <p:extLst>
+      <p:ext uri="{BB962C8B-B14F-4D97-AF65-F5344CB8AC3E}">
+        <p14:creationId xmlns:p14="http://schemas.microsoft.com/office/powerpoint/2010/main" val="1120305369"/>
+      </p:ext>
+    </p:extLst>
+  </p:cSld>
+  <p:clrMapOvr>
+    <a:masterClrMapping/>
+  </p:clrMapOvr>
+</p:notes>
+</file>
+
+<file path=ppt/notesSlides/notesSlide11.xml><?xml version="1.0" encoding="utf-8"?>
+<p:notes xmlns:a="http://schemas.openxmlformats.org/drawingml/2006/main" xmlns:r="http://schemas.openxmlformats.org/officeDocument/2006/relationships" xmlns:p="http://schemas.openxmlformats.org/presentationml/2006/main" showMasterSp="0" showMasterPhAnim="0">
+  <p:cSld>
+    <p:spTree>
+      <p:nvGrpSpPr>
         <p:cNvPr id="1" name="Shape 481"/>
         <p:cNvGrpSpPr/>
         <p:nvPr/>
@@ -746,7 +873,7 @@
 </p:notes>
 </file>
 
-<file path=ppt/notesSlides/notesSlide11.xml><?xml version="1.0" encoding="utf-8"?>
+<file path=ppt/notesSlides/notesSlide12.xml><?xml version="1.0" encoding="utf-8"?>
 <p:notes xmlns:a="http://schemas.openxmlformats.org/drawingml/2006/main" xmlns:r="http://schemas.openxmlformats.org/officeDocument/2006/relationships" xmlns:p="http://schemas.openxmlformats.org/presentationml/2006/main" showMasterSp="0" showMasterPhAnim="0">
   <p:cSld>
     <p:spTree>
@@ -868,7 +995,7 @@
 </p:notes>
 </file>
 
-<file path=ppt/notesSlides/notesSlide12.xml><?xml version="1.0" encoding="utf-8"?>
+<file path=ppt/notesSlides/notesSlide13.xml><?xml version="1.0" encoding="utf-8"?>
 <p:notes xmlns:a="http://schemas.openxmlformats.org/drawingml/2006/main" xmlns:r="http://schemas.openxmlformats.org/officeDocument/2006/relationships" xmlns:p="http://schemas.openxmlformats.org/presentationml/2006/main" showMasterSp="0" showMasterPhAnim="0">
   <p:cSld>
     <p:spTree>
@@ -1435,6 +1562,90 @@
 </file>
 
 <file path=ppt/notesSlides/notesSlide6.xml><?xml version="1.0" encoding="utf-8"?>
+<p:notes xmlns:a="http://schemas.openxmlformats.org/drawingml/2006/main" xmlns:r="http://schemas.openxmlformats.org/officeDocument/2006/relationships" xmlns:p="http://schemas.openxmlformats.org/presentationml/2006/main">
+  <p:cSld>
+    <p:spTree>
+      <p:nvGrpSpPr>
+        <p:cNvPr id="1" name=""/>
+        <p:cNvGrpSpPr/>
+        <p:nvPr/>
+      </p:nvGrpSpPr>
+      <p:grpSpPr>
+        <a:xfrm>
+          <a:off x="0" y="0"/>
+          <a:ext cx="0" cy="0"/>
+          <a:chOff x="0" y="0"/>
+          <a:chExt cx="0" cy="0"/>
+        </a:xfrm>
+      </p:grpSpPr>
+      <p:sp>
+        <p:nvSpPr>
+          <p:cNvPr id="2" name="Slide Image Placeholder 1"/>
+          <p:cNvSpPr>
+            <a:spLocks noGrp="1" noRot="1" noChangeAspect="1"/>
+          </p:cNvSpPr>
+          <p:nvPr>
+            <p:ph type="sldImg"/>
+          </p:nvPr>
+        </p:nvSpPr>
+        <p:spPr/>
+      </p:sp>
+      <p:sp>
+        <p:nvSpPr>
+          <p:cNvPr id="3" name="Notes Placeholder 2"/>
+          <p:cNvSpPr>
+            <a:spLocks noGrp="1"/>
+          </p:cNvSpPr>
+          <p:nvPr>
+            <p:ph type="body" idx="1"/>
+          </p:nvPr>
+        </p:nvSpPr>
+        <p:spPr/>
+        <p:txBody>
+          <a:bodyPr/>
+          <a:lstStyle/>
+          <a:p>
+            <a:endParaRPr lang="en-US" dirty="0"/>
+          </a:p>
+        </p:txBody>
+      </p:sp>
+      <p:sp>
+        <p:nvSpPr>
+          <p:cNvPr id="4" name="Slide Number Placeholder 3"/>
+          <p:cNvSpPr>
+            <a:spLocks noGrp="1"/>
+          </p:cNvSpPr>
+          <p:nvPr>
+            <p:ph type="sldNum" sz="quarter" idx="5"/>
+          </p:nvPr>
+        </p:nvSpPr>
+        <p:spPr/>
+        <p:txBody>
+          <a:bodyPr/>
+          <a:lstStyle/>
+          <a:p>
+            <a:fld id="{89375BB5-C319-4CC0-9F8F-8FE78AD357CB}" type="slidenum">
+              <a:rPr lang="ru-RU" smtClean="0"/>
+              <a:t>26</a:t>
+            </a:fld>
+            <a:endParaRPr lang="ru-RU"/>
+          </a:p>
+        </p:txBody>
+      </p:sp>
+    </p:spTree>
+    <p:extLst>
+      <p:ext uri="{BB962C8B-B14F-4D97-AF65-F5344CB8AC3E}">
+        <p14:creationId xmlns:p14="http://schemas.microsoft.com/office/powerpoint/2010/main" val="1677563816"/>
+      </p:ext>
+    </p:extLst>
+  </p:cSld>
+  <p:clrMapOvr>
+    <a:masterClrMapping/>
+  </p:clrMapOvr>
+</p:notes>
+</file>
+
+<file path=ppt/notesSlides/notesSlide7.xml><?xml version="1.0" encoding="utf-8"?>
 <p:notes xmlns:a="http://schemas.openxmlformats.org/drawingml/2006/main" xmlns:r="http://schemas.openxmlformats.org/officeDocument/2006/relationships" xmlns:p="http://schemas.openxmlformats.org/presentationml/2006/main" showMasterSp="0" showMasterPhAnim="0">
   <p:cSld>
     <p:spTree>
@@ -1556,7 +1767,7 @@
 </p:notes>
 </file>
 
-<file path=ppt/notesSlides/notesSlide7.xml><?xml version="1.0" encoding="utf-8"?>
+<file path=ppt/notesSlides/notesSlide8.xml><?xml version="1.0" encoding="utf-8"?>
 <p:notes xmlns:a="http://schemas.openxmlformats.org/drawingml/2006/main" xmlns:r="http://schemas.openxmlformats.org/officeDocument/2006/relationships" xmlns:p="http://schemas.openxmlformats.org/presentationml/2006/main" showMasterSp="0" showMasterPhAnim="0">
   <p:cSld>
     <p:spTree>
@@ -1665,7 +1876,7 @@
 </p:notes>
 </file>
 
-<file path=ppt/notesSlides/notesSlide8.xml><?xml version="1.0" encoding="utf-8"?>
+<file path=ppt/notesSlides/notesSlide9.xml><?xml version="1.0" encoding="utf-8"?>
 <p:notes xmlns:a="http://schemas.openxmlformats.org/drawingml/2006/main" xmlns:r="http://schemas.openxmlformats.org/officeDocument/2006/relationships" xmlns:p="http://schemas.openxmlformats.org/presentationml/2006/main" showMasterSp="0" showMasterPhAnim="0">
   <p:cSld>
     <p:spTree>
@@ -1769,133 +1980,6 @@
 </p:notes>
 </file>
 
-<file path=ppt/notesSlides/notesSlide9.xml><?xml version="1.0" encoding="utf-8"?>
-<p:notes xmlns:a="http://schemas.openxmlformats.org/drawingml/2006/main" xmlns:r="http://schemas.openxmlformats.org/officeDocument/2006/relationships" xmlns:p="http://schemas.openxmlformats.org/presentationml/2006/main" showMasterSp="0" showMasterPhAnim="0">
-  <p:cSld>
-    <p:spTree>
-      <p:nvGrpSpPr>
-        <p:cNvPr id="1" name="Shape 476"/>
-        <p:cNvGrpSpPr/>
-        <p:nvPr/>
-      </p:nvGrpSpPr>
-      <p:grpSpPr>
-        <a:xfrm>
-          <a:off x="0" y="0"/>
-          <a:ext cx="0" cy="0"/>
-          <a:chOff x="0" y="0"/>
-          <a:chExt cx="0" cy="0"/>
-        </a:xfrm>
-      </p:grpSpPr>
-      <p:sp>
-        <p:nvSpPr>
-          <p:cNvPr id="477" name="Google Shape;477;p45:notes"/>
-          <p:cNvSpPr>
-            <a:spLocks noGrp="1" noRot="1" noChangeAspect="1"/>
-          </p:cNvSpPr>
-          <p:nvPr>
-            <p:ph type="sldImg" idx="2"/>
-          </p:nvPr>
-        </p:nvSpPr>
-        <p:spPr>
-          <a:xfrm>
-            <a:off x="381000" y="685800"/>
-            <a:ext cx="6096000" cy="3429000"/>
-          </a:xfrm>
-          <a:custGeom>
-            <a:avLst/>
-            <a:gdLst/>
-            <a:ahLst/>
-            <a:cxnLst/>
-            <a:rect l="l" t="t" r="r" b="b"/>
-            <a:pathLst>
-              <a:path w="120000" h="120000" extrusionOk="0">
-                <a:moveTo>
-                  <a:pt x="0" y="0"/>
-                </a:moveTo>
-                <a:lnTo>
-                  <a:pt x="120000" y="0"/>
-                </a:lnTo>
-                <a:lnTo>
-                  <a:pt x="120000" y="120000"/>
-                </a:lnTo>
-                <a:lnTo>
-                  <a:pt x="0" y="120000"/>
-                </a:lnTo>
-                <a:close/>
-              </a:path>
-            </a:pathLst>
-          </a:custGeom>
-          <a:noFill/>
-          <a:ln w="9525" cap="flat" cmpd="sng">
-            <a:solidFill>
-              <a:srgbClr val="000000"/>
-            </a:solidFill>
-            <a:prstDash val="solid"/>
-            <a:round/>
-            <a:headEnd type="none" w="sm" len="sm"/>
-            <a:tailEnd type="none" w="sm" len="sm"/>
-          </a:ln>
-        </p:spPr>
-      </p:sp>
-      <p:sp>
-        <p:nvSpPr>
-          <p:cNvPr id="478" name="Google Shape;478;p45:notes"/>
-          <p:cNvSpPr txBox="1">
-            <a:spLocks noGrp="1"/>
-          </p:cNvSpPr>
-          <p:nvPr>
-            <p:ph type="body" idx="1"/>
-          </p:nvPr>
-        </p:nvSpPr>
-        <p:spPr>
-          <a:xfrm>
-            <a:off x="685800" y="4343400"/>
-            <a:ext cx="5486400" cy="4114800"/>
-          </a:xfrm>
-          <a:prstGeom prst="rect">
-            <a:avLst/>
-          </a:prstGeom>
-          <a:noFill/>
-          <a:ln>
-            <a:noFill/>
-          </a:ln>
-        </p:spPr>
-        <p:txBody>
-          <a:bodyPr spcFirstLastPara="1" wrap="square" lIns="91425" tIns="91425" rIns="91425" bIns="91425" anchor="t" anchorCtr="0">
-            <a:noAutofit/>
-          </a:bodyPr>
-          <a:lstStyle/>
-          <a:p>
-            <a:pPr marL="0" lvl="0" indent="0" algn="l" rtl="0">
-              <a:lnSpc>
-                <a:spcPct val="100000"/>
-              </a:lnSpc>
-              <a:spcBef>
-                <a:spcPts val="0"/>
-              </a:spcBef>
-              <a:spcAft>
-                <a:spcPts val="0"/>
-              </a:spcAft>
-              <a:buSzPts val="1100"/>
-              <a:buNone/>
-            </a:pPr>
-            <a:endParaRPr/>
-          </a:p>
-        </p:txBody>
-      </p:sp>
-    </p:spTree>
-    <p:extLst>
-      <p:ext uri="{BB962C8B-B14F-4D97-AF65-F5344CB8AC3E}">
-        <p14:creationId xmlns:p14="http://schemas.microsoft.com/office/powerpoint/2010/main" val="1120305369"/>
-      </p:ext>
-    </p:extLst>
-  </p:cSld>
-  <p:clrMapOvr>
-    <a:masterClrMapping/>
-  </p:clrMapOvr>
-</p:notes>
-</file>
-
 <file path=ppt/slideLayouts/slideLayout1.xml><?xml version="1.0" encoding="utf-8"?>
 <p:sldLayout xmlns:a="http://schemas.openxmlformats.org/drawingml/2006/main" xmlns:r="http://schemas.openxmlformats.org/officeDocument/2006/relationships" xmlns:p="http://schemas.openxmlformats.org/presentationml/2006/main" type="obj" preserve="1">
   <p:cSld name="Title Slide">
@@ -2039,7 +2123,7 @@
           <a:p>
             <a:fld id="{1D8BD707-D9CF-40AE-B4C6-C98DA3205C09}" type="datetimeFigureOut">
               <a:rPr lang="en-US"/>
-              <a:t>10/19/24</a:t>
+              <a:t>1/22/25</a:t>
             </a:fld>
             <a:endParaRPr lang="en-US"/>
           </a:p>
@@ -2214,7 +2298,7 @@
           <a:p>
             <a:fld id="{1D8BD707-D9CF-40AE-B4C6-C98DA3205C09}" type="datetimeFigureOut">
               <a:rPr lang="en-US"/>
-              <a:t>10/19/24</a:t>
+              <a:t>1/22/25</a:t>
             </a:fld>
             <a:endParaRPr lang="en-US"/>
           </a:p>
@@ -2470,7 +2554,7 @@
           <a:p>
             <a:fld id="{1D8BD707-D9CF-40AE-B4C6-C98DA3205C09}" type="datetimeFigureOut">
               <a:rPr lang="en-US"/>
-              <a:t>10/19/24</a:t>
+              <a:t>1/22/25</a:t>
             </a:fld>
             <a:endParaRPr lang="en-US"/>
           </a:p>
@@ -2648,7 +2732,7 @@
           <a:p>
             <a:fld id="{1D8BD707-D9CF-40AE-B4C6-C98DA3205C09}" type="datetimeFigureOut">
               <a:rPr lang="en-US"/>
-              <a:t>10/19/24</a:t>
+              <a:t>1/22/25</a:t>
             </a:fld>
             <a:endParaRPr lang="en-US"/>
           </a:p>
@@ -2767,7 +2851,7 @@
           <a:p>
             <a:fld id="{1D8BD707-D9CF-40AE-B4C6-C98DA3205C09}" type="datetimeFigureOut">
               <a:rPr lang="en-US"/>
-              <a:t>10/19/24</a:t>
+              <a:t>1/22/25</a:t>
             </a:fld>
             <a:endParaRPr lang="en-US"/>
           </a:p>
@@ -5468,7 +5552,7 @@
           <a:p>
             <a:fld id="{1D8BD707-D9CF-40AE-B4C6-C98DA3205C09}" type="datetimeFigureOut">
               <a:rPr lang="en-US"/>
-              <a:t>10/19/24</a:t>
+              <a:t>1/22/25</a:t>
             </a:fld>
             <a:endParaRPr lang="en-US"/>
           </a:p>
@@ -9460,11 +9544,17 @@
           <p:cNvGraphicFramePr>
             <a:graphicFrameLocks noGrp="1"/>
           </p:cNvGraphicFramePr>
-          <p:nvPr/>
+          <p:nvPr>
+            <p:extLst>
+              <p:ext uri="{D42A27DB-BD31-4B8C-83A1-F6EECF244321}">
+                <p14:modId xmlns:p14="http://schemas.microsoft.com/office/powerpoint/2010/main" val="2145645613"/>
+              </p:ext>
+            </p:extLst>
+          </p:nvPr>
         </p:nvGraphicFramePr>
         <p:xfrm>
-          <a:off x="928750" y="1817045"/>
-          <a:ext cx="7664200" cy="1630680"/>
+          <a:off x="928750" y="1733550"/>
+          <a:ext cx="7664200" cy="1752600"/>
         </p:xfrm>
         <a:graphic>
           <a:graphicData uri="http://schemas.openxmlformats.org/drawingml/2006/table">
@@ -9485,14 +9575,14 @@
                     </a:ext>
                   </a:extLst>
                 </a:gridCol>
-                <a:gridCol w="1532840">
+                <a:gridCol w="1644370">
                   <a:extLst>
                     <a:ext uri="{9D8B030D-6E8A-4147-A177-3AD203B41FA5}">
                       <a16:colId xmlns:a16="http://schemas.microsoft.com/office/drawing/2014/main" val="3718487918"/>
                     </a:ext>
                   </a:extLst>
                 </a:gridCol>
-                <a:gridCol w="1532840">
+                <a:gridCol w="1421310">
                   <a:extLst>
                     <a:ext uri="{9D8B030D-6E8A-4147-A177-3AD203B41FA5}">
                       <a16:colId xmlns:a16="http://schemas.microsoft.com/office/drawing/2014/main" val="16787471"/>
@@ -9940,7 +10030,7 @@
         </p:nvSpPr>
         <p:spPr>
           <a:xfrm>
-            <a:off x="2464340" y="2334638"/>
+            <a:off x="2464340" y="2365848"/>
             <a:ext cx="4584971" cy="739302"/>
           </a:xfrm>
           <a:prstGeom prst="roundRect">
@@ -10351,11 +10441,17 @@
           <p:cNvGraphicFramePr>
             <a:graphicFrameLocks noGrp="1"/>
           </p:cNvGraphicFramePr>
-          <p:nvPr/>
+          <p:nvPr>
+            <p:extLst>
+              <p:ext uri="{D42A27DB-BD31-4B8C-83A1-F6EECF244321}">
+                <p14:modId xmlns:p14="http://schemas.microsoft.com/office/powerpoint/2010/main" val="4046189197"/>
+              </p:ext>
+            </p:extLst>
+          </p:nvPr>
         </p:nvGraphicFramePr>
         <p:xfrm>
           <a:off x="928750" y="1817045"/>
-          <a:ext cx="7664200" cy="1630680"/>
+          <a:ext cx="7664200" cy="1752600"/>
         </p:xfrm>
         <a:graphic>
           <a:graphicData uri="http://schemas.openxmlformats.org/drawingml/2006/table">
@@ -10376,14 +10472,14 @@
                     </a:ext>
                   </a:extLst>
                 </a:gridCol>
-                <a:gridCol w="1532840">
+                <a:gridCol w="1644370">
                   <a:extLst>
                     <a:ext uri="{9D8B030D-6E8A-4147-A177-3AD203B41FA5}">
                       <a16:colId xmlns:a16="http://schemas.microsoft.com/office/drawing/2014/main" val="3718487918"/>
                     </a:ext>
                   </a:extLst>
                 </a:gridCol>
-                <a:gridCol w="1532840">
+                <a:gridCol w="1421310">
                   <a:extLst>
                     <a:ext uri="{9D8B030D-6E8A-4147-A177-3AD203B41FA5}">
                       <a16:colId xmlns:a16="http://schemas.microsoft.com/office/drawing/2014/main" val="16787471"/>
@@ -10831,7 +10927,7 @@
         </p:nvSpPr>
         <p:spPr>
           <a:xfrm>
-            <a:off x="2464340" y="2334638"/>
+            <a:off x="2464340" y="2442048"/>
             <a:ext cx="4584971" cy="739302"/>
           </a:xfrm>
           <a:prstGeom prst="roundRect">
@@ -10880,7 +10976,7 @@
         </p:nvCxnSpPr>
         <p:spPr>
           <a:xfrm>
-            <a:off x="7023370" y="3028544"/>
+            <a:off x="7023370" y="3105150"/>
             <a:ext cx="596630" cy="233464"/>
           </a:xfrm>
           <a:prstGeom prst="straightConnector1">
@@ -11091,11 +11187,17 @@
           <p:cNvGraphicFramePr>
             <a:graphicFrameLocks noGrp="1"/>
           </p:cNvGraphicFramePr>
-          <p:nvPr/>
+          <p:nvPr>
+            <p:extLst>
+              <p:ext uri="{D42A27DB-BD31-4B8C-83A1-F6EECF244321}">
+                <p14:modId xmlns:p14="http://schemas.microsoft.com/office/powerpoint/2010/main" val="2177788890"/>
+              </p:ext>
+            </p:extLst>
+          </p:nvPr>
         </p:nvGraphicFramePr>
         <p:xfrm>
-          <a:off x="928750" y="1817045"/>
-          <a:ext cx="7664200" cy="1630680"/>
+          <a:off x="928750" y="1657350"/>
+          <a:ext cx="7664200" cy="1752600"/>
         </p:xfrm>
         <a:graphic>
           <a:graphicData uri="http://schemas.openxmlformats.org/drawingml/2006/table">
@@ -11116,14 +11218,14 @@
                     </a:ext>
                   </a:extLst>
                 </a:gridCol>
-                <a:gridCol w="1532840">
+                <a:gridCol w="1644370">
                   <a:extLst>
                     <a:ext uri="{9D8B030D-6E8A-4147-A177-3AD203B41FA5}">
                       <a16:colId xmlns:a16="http://schemas.microsoft.com/office/drawing/2014/main" val="3718487918"/>
                     </a:ext>
                   </a:extLst>
                 </a:gridCol>
-                <a:gridCol w="1532840">
+                <a:gridCol w="1421310">
                   <a:extLst>
                     <a:ext uri="{9D8B030D-6E8A-4147-A177-3AD203B41FA5}">
                       <a16:colId xmlns:a16="http://schemas.microsoft.com/office/drawing/2014/main" val="16787471"/>
@@ -11571,7 +11673,7 @@
         </p:nvSpPr>
         <p:spPr>
           <a:xfrm>
-            <a:off x="2464340" y="2334638"/>
+            <a:off x="2464340" y="2289648"/>
             <a:ext cx="4584971" cy="739302"/>
           </a:xfrm>
           <a:prstGeom prst="roundRect">
@@ -11620,7 +11722,7 @@
         </p:nvCxnSpPr>
         <p:spPr>
           <a:xfrm>
-            <a:off x="7023370" y="3028544"/>
+            <a:off x="7023370" y="2952750"/>
             <a:ext cx="596630" cy="233464"/>
           </a:xfrm>
           <a:prstGeom prst="straightConnector1">
@@ -11662,10 +11764,10 @@
         </p:nvGrpSpPr>
         <p:grpSpPr>
           <a:xfrm>
-            <a:off x="928750" y="3728936"/>
-            <a:ext cx="6870792" cy="712503"/>
+            <a:off x="928750" y="3743071"/>
+            <a:ext cx="6870792" cy="852771"/>
             <a:chOff x="928750" y="3728936"/>
-            <a:chExt cx="6870792" cy="712503"/>
+            <a:chExt cx="6870792" cy="852771"/>
           </a:xfrm>
         </p:grpSpPr>
         <mc:AlternateContent xmlns:mc="http://schemas.openxmlformats.org/markup-compatibility/2006" xmlns:a14="http://schemas.microsoft.com/office/drawing/2010/main">
@@ -12010,7 +12112,7 @@
           </p:nvCxnSpPr>
           <p:spPr>
             <a:xfrm flipH="1">
-              <a:off x="5486400" y="4226086"/>
+              <a:off x="6673174" y="4250922"/>
               <a:ext cx="350196" cy="181157"/>
             </a:xfrm>
             <a:prstGeom prst="line">
@@ -12046,7 +12148,7 @@
           </p:nvCxnSpPr>
           <p:spPr>
             <a:xfrm flipH="1">
-              <a:off x="5943600" y="4134681"/>
+              <a:off x="6126804" y="4400550"/>
               <a:ext cx="350196" cy="181157"/>
             </a:xfrm>
             <a:prstGeom prst="line">
@@ -12204,8 +12306,8 @@
           </a:p>
         </p:txBody>
       </p:sp>
-      <mc:AlternateContent xmlns:mc="http://schemas.openxmlformats.org/markup-compatibility/2006" xmlns:a14="http://schemas.microsoft.com/office/drawing/2010/main">
-        <mc:Choice Requires="a14">
+      <mc:AlternateContent xmlns:mc="http://schemas.openxmlformats.org/markup-compatibility/2006">
+        <mc:Choice xmlns:a14="http://schemas.microsoft.com/office/drawing/2010/main" Requires="a14">
           <p:graphicFrame>
             <p:nvGraphicFramePr>
               <p:cNvPr id="3" name="Table 5">
@@ -12218,10 +12320,16 @@
               <p:cNvGraphicFramePr>
                 <a:graphicFrameLocks noGrp="1"/>
               </p:cNvGraphicFramePr>
-              <p:nvPr/>
+              <p:nvPr>
+                <p:extLst>
+                  <p:ext uri="{D42A27DB-BD31-4B8C-83A1-F6EECF244321}">
+                    <p14:modId xmlns:p14="http://schemas.microsoft.com/office/powerpoint/2010/main" val="3847608926"/>
+                  </p:ext>
+                </p:extLst>
+              </p:nvPr>
             </p:nvGraphicFramePr>
             <p:xfrm>
-              <a:off x="928750" y="1817045"/>
+              <a:off x="928750" y="1628520"/>
               <a:ext cx="7664200" cy="1769492"/>
             </p:xfrm>
             <a:graphic>
@@ -13159,7 +13267,7 @@
             </a:graphic>
           </p:graphicFrame>
         </mc:Choice>
-        <mc:Fallback xmlns="">
+        <mc:Fallback>
           <p:graphicFrame>
             <p:nvGraphicFramePr>
               <p:cNvPr id="3" name="Table 5">
@@ -13175,21 +13283,19 @@
               <p:nvPr>
                 <p:extLst>
                   <p:ext uri="{D42A27DB-BD31-4B8C-83A1-F6EECF244321}">
-                    <p14:modId xmlns:p14="http://schemas.microsoft.com/office/powerpoint/2010/main" val="1825612613"/>
+                    <p14:modId xmlns:p14="http://schemas.microsoft.com/office/powerpoint/2010/main" val="3847608926"/>
                   </p:ext>
                 </p:extLst>
               </p:nvPr>
             </p:nvGraphicFramePr>
             <p:xfrm>
-              <a:off x="928750" y="1817045"/>
-              <a:ext cx="7664200" cy="1647572"/>
+              <a:off x="928750" y="1628520"/>
+              <a:ext cx="7664200" cy="1769492"/>
             </p:xfrm>
             <a:graphic>
               <a:graphicData uri="http://schemas.openxmlformats.org/drawingml/2006/table">
                 <a:tbl>
-                  <a:tblPr firstRow="1" bandRow="1">
-                    <a:tableStyleId>{23E6A93D-E22E-496A-AE55-A62C1E3046BF}</a:tableStyleId>
-                  </a:tblPr>
+                  <a:tblPr firstRow="1" bandRow="1"/>
                   <a:tblGrid>
                     <a:gridCol w="1532840">
                       <a:extLst>
@@ -13227,7 +13333,7 @@
                       </a:extLst>
                     </a:gridCol>
                   </a:tblGrid>
-                  <a:tr h="518160">
+                  <a:tr h="640080">
                     <a:tc>
                       <a:txBody>
                         <a:bodyPr/>
@@ -13338,9 +13444,9 @@
                       </a:txBody>
                       <a:tcPr>
                         <a:blipFill>
-                          <a:blip r:embed="rId2"/>
+                          <a:blip r:embed="rId3"/>
                           <a:stretch>
-                            <a:fillRect l="-100826" t="-140000" r="-300000" b="-200000"/>
+                            <a:fillRect l="-100826" t="-176667" r="-300000" b="-223333"/>
                           </a:stretch>
                         </a:blipFill>
                       </a:tcPr>
@@ -13355,9 +13461,9 @@
                       </a:txBody>
                       <a:tcPr>
                         <a:blipFill>
-                          <a:blip r:embed="rId2"/>
+                          <a:blip r:embed="rId3"/>
                           <a:stretch>
-                            <a:fillRect l="-202500" t="-140000" r="-202500" b="-200000"/>
+                            <a:fillRect l="-202500" t="-176667" r="-202500" b="-223333"/>
                           </a:stretch>
                         </a:blipFill>
                       </a:tcPr>
@@ -13372,9 +13478,9 @@
                       </a:txBody>
                       <a:tcPr>
                         <a:blipFill>
-                          <a:blip r:embed="rId2"/>
+                          <a:blip r:embed="rId3"/>
                           <a:stretch>
-                            <a:fillRect l="-300000" t="-140000" r="-100826" b="-200000"/>
+                            <a:fillRect l="-300000" t="-176667" r="-100826" b="-223333"/>
                           </a:stretch>
                         </a:blipFill>
                       </a:tcPr>
@@ -13439,9 +13545,9 @@
                       </a:txBody>
                       <a:tcPr>
                         <a:blipFill>
-                          <a:blip r:embed="rId2"/>
+                          <a:blip r:embed="rId3"/>
                           <a:stretch>
-                            <a:fillRect l="-100826" t="-240000" r="-300000" b="-100000"/>
+                            <a:fillRect l="-100826" t="-276667" r="-300000" b="-123333"/>
                           </a:stretch>
                         </a:blipFill>
                       </a:tcPr>
@@ -13456,9 +13562,9 @@
                       </a:txBody>
                       <a:tcPr>
                         <a:blipFill>
-                          <a:blip r:embed="rId2"/>
+                          <a:blip r:embed="rId3"/>
                           <a:stretch>
-                            <a:fillRect l="-202500" t="-240000" r="-202500" b="-100000"/>
+                            <a:fillRect l="-202500" t="-276667" r="-202500" b="-123333"/>
                           </a:stretch>
                         </a:blipFill>
                       </a:tcPr>
@@ -13473,9 +13579,9 @@
                       </a:txBody>
                       <a:tcPr>
                         <a:blipFill>
-                          <a:blip r:embed="rId2"/>
+                          <a:blip r:embed="rId3"/>
                           <a:stretch>
-                            <a:fillRect l="-300000" t="-240000" r="-100826" b="-100000"/>
+                            <a:fillRect l="-300000" t="-276667" r="-100826" b="-123333"/>
                           </a:stretch>
                         </a:blipFill>
                       </a:tcPr>
@@ -13638,7 +13744,7 @@
         </p:nvSpPr>
         <p:spPr>
           <a:xfrm>
-            <a:off x="928750" y="1189087"/>
+            <a:off x="928750" y="1000562"/>
             <a:ext cx="2294218" cy="307777"/>
           </a:xfrm>
           <a:prstGeom prst="rect">
@@ -13674,7 +13780,7 @@
         </p:nvSpPr>
         <p:spPr>
           <a:xfrm>
-            <a:off x="6308350" y="1496864"/>
+            <a:off x="6308350" y="1308339"/>
             <a:ext cx="2074607" cy="307777"/>
           </a:xfrm>
           <a:prstGeom prst="rect">
@@ -13710,7 +13816,7 @@
         </p:nvSpPr>
         <p:spPr>
           <a:xfrm>
-            <a:off x="928751" y="3800524"/>
+            <a:off x="928751" y="3611999"/>
             <a:ext cx="7664200" cy="1169551"/>
           </a:xfrm>
           <a:prstGeom prst="rect">
@@ -14842,7 +14948,7 @@
         </p:nvSpPr>
         <p:spPr>
           <a:xfrm>
-            <a:off x="3962402" y="4429328"/>
+            <a:off x="4049950" y="4427061"/>
             <a:ext cx="1284050" cy="430689"/>
           </a:xfrm>
           <a:prstGeom prst="roundRect">
@@ -17844,8 +17950,8 @@
           </a:p>
         </p:txBody>
       </p:sp>
-      <mc:AlternateContent xmlns:mc="http://schemas.openxmlformats.org/markup-compatibility/2006">
-        <mc:Choice xmlns:a14="http://schemas.microsoft.com/office/drawing/2010/main" Requires="a14">
+      <mc:AlternateContent xmlns:mc="http://schemas.openxmlformats.org/markup-compatibility/2006" xmlns:a14="http://schemas.microsoft.com/office/drawing/2010/main">
+        <mc:Choice Requires="a14">
           <p:sp>
             <p:nvSpPr>
               <p:cNvPr id="4" name="TextBox 3">
@@ -18087,7 +18193,7 @@
             </p:txBody>
           </p:sp>
         </mc:Choice>
-        <mc:Fallback>
+        <mc:Fallback xmlns="">
           <p:sp>
             <p:nvSpPr>
               <p:cNvPr id="4" name="TextBox 3">
@@ -20732,11 +20838,15 @@
               <a:buAutoNum type="arabicPeriod"/>
             </a:pPr>
             <a:r>
-              <a:rPr lang="ru-RU" dirty="0"/>
+              <a:rPr lang="ru-RU" dirty="0">
+                <a:hlinkClick r:id="rId3"/>
+              </a:rPr>
               <a:t>Статистика для всех. Сара </a:t>
             </a:r>
             <a:r>
-              <a:rPr lang="ru-RU" dirty="0" err="1"/>
+              <a:rPr lang="ru-RU" dirty="0" err="1">
+                <a:hlinkClick r:id="rId3"/>
+              </a:rPr>
               <a:t>Бослаф</a:t>
             </a:r>
             <a:endParaRPr lang="ru-RU" dirty="0"/>
@@ -20753,9 +20863,12 @@
               <a:buAutoNum type="arabicPeriod"/>
             </a:pPr>
             <a:r>
-              <a:rPr lang="ru-RU" dirty="0"/>
+              <a:rPr lang="ru-RU" dirty="0">
+                <a:hlinkClick r:id="rId4"/>
+              </a:rPr>
               <a:t>Статистика и котики. Владимир Савельев</a:t>
             </a:r>
+            <a:endParaRPr lang="ru-RU" dirty="0"/>
           </a:p>
           <a:p>
             <a:pPr marL="457200" indent="-311150" algn="l" rtl="0">
@@ -20769,11 +20882,15 @@
               <a:buAutoNum type="arabicPeriod"/>
             </a:pPr>
             <a:r>
-              <a:rPr lang="ru-RU" dirty="0"/>
+              <a:rPr lang="ru-RU" dirty="0">
+                <a:hlinkClick r:id="rId5"/>
+              </a:rPr>
               <a:t>Голая статистика. Чарльз </a:t>
             </a:r>
             <a:r>
-              <a:rPr lang="ru-RU" dirty="0" err="1"/>
+              <a:rPr lang="ru-RU" dirty="0" err="1">
+                <a:hlinkClick r:id="rId5"/>
+              </a:rPr>
               <a:t>Уилан</a:t>
             </a:r>
             <a:endParaRPr lang="ru-RU" dirty="0"/>
@@ -20790,19 +20907,27 @@
               <a:buAutoNum type="arabicPeriod"/>
             </a:pPr>
             <a:r>
-              <a:rPr lang="ru-RU" dirty="0"/>
+              <a:rPr lang="ru-RU" dirty="0">
+                <a:hlinkClick r:id="rId6"/>
+              </a:rPr>
               <a:t>Как лгать при помощи статистики. </a:t>
             </a:r>
             <a:r>
-              <a:rPr lang="ru-RU" dirty="0" err="1"/>
+              <a:rPr lang="ru-RU" dirty="0" err="1">
+                <a:hlinkClick r:id="rId6"/>
+              </a:rPr>
               <a:t>Дарелл</a:t>
             </a:r>
             <a:r>
-              <a:rPr lang="ru-RU" dirty="0"/>
+              <a:rPr lang="ru-RU" dirty="0">
+                <a:hlinkClick r:id="rId6"/>
+              </a:rPr>
               <a:t> </a:t>
             </a:r>
             <a:r>
-              <a:rPr lang="ru-RU" dirty="0" err="1"/>
+              <a:rPr lang="ru-RU" dirty="0" err="1">
+                <a:hlinkClick r:id="rId6"/>
+              </a:rPr>
               <a:t>Хафф</a:t>
             </a:r>
             <a:endParaRPr lang="ru-RU" dirty="0"/>

</xml_diff>